<commit_message>
chore: update example output files
</commit_message>
<xml_diff>
--- a/examples/output/pptx/01-basic.pptx
+++ b/examples/output/pptx/01-basic.pptx
@@ -2,9 +2,9 @@
 <file path=ppt/presentation.xml><?xml version="1.0" encoding="utf-8"?>
 <p:presentation xmlns:p="http://schemas.openxmlformats.org/presentationml/2006/main">
   <p:sldIdLst>
-    <p:sldId xmlns:r="http://schemas.openxmlformats.org/officeDocument/2006/relationships" id="257" r:id="R65ec80528ed442d0"/>
-    <p:sldId xmlns:r="http://schemas.openxmlformats.org/officeDocument/2006/relationships" id="258" r:id="R6a6bd6d543ec40d9"/>
-    <p:sldId xmlns:r="http://schemas.openxmlformats.org/officeDocument/2006/relationships" id="259" r:id="R434bf16c29db4917"/>
+    <p:sldId xmlns:r="http://schemas.openxmlformats.org/officeDocument/2006/relationships" id="257" r:id="R4a7f1897eceb47a2"/>
+    <p:sldId xmlns:r="http://schemas.openxmlformats.org/officeDocument/2006/relationships" id="258" r:id="R2228115148594fe0"/>
+    <p:sldId xmlns:r="http://schemas.openxmlformats.org/officeDocument/2006/relationships" id="259" r:id="Ra835377fb34843bd"/>
   </p:sldIdLst>
 </p:presentation>
 </file>
@@ -59,7 +59,7 @@
   </p:cSld>
   <p:clrMap/>
   <p:sldLayoutIdLst>
-    <p:sldLayoutId xmlns:r="http://schemas.openxmlformats.org/officeDocument/2006/relationships" id="1" r:id="R2994cfdf2fca4b2e"/>
+    <p:sldLayoutId xmlns:r="http://schemas.openxmlformats.org/officeDocument/2006/relationships" id="1" r:id="R62ba02340c854b54"/>
   </p:sldLayoutIdLst>
 </p:sldMaster>
 </file>

</xml_diff>